<commit_message>
Improved UI and Log Stream from Agno
</commit_message>
<xml_diff>
--- a/services/agno_service/output.pptx
+++ b/services/agno_service/output.pptx
@@ -14,6 +14,10 @@
     <p:sldId id="262" r:id="rId13"/>
     <p:sldId id="263" r:id="rId14"/>
     <p:sldId id="264" r:id="rId15"/>
+    <p:sldId id="265" r:id="rId16"/>
+    <p:sldId id="266" r:id="rId17"/>
+    <p:sldId id="267" r:id="rId18"/>
+    <p:sldId id="268" r:id="rId19"/>
   </p:sldIdLst>
   <p:sldSz cx="9144000" cy="6858000" type="screen4x3"/>
   <p:notesSz cx="6858000" cy="9144000"/>
@@ -3144,7 +3148,7 @@
               <a:defRPr sz="2000"/>
             </a:pPr>
             <a:r>
-              <a:t>Key capabilities and applications</a:t>
+              <a:t>Key capabilities: text, image, audio, video</a:t>
             </a:r>
           </a:p>
           <a:p>
@@ -3153,6 +3157,322 @@
             </a:pPr>
             <a:r>
               <a:t>Brief history and evolution</a:t>
+            </a:r>
+          </a:p>
+        </p:txBody>
+      </p:sp>
+    </p:spTree>
+  </p:cSld>
+  <p:clrMapOvr>
+    <a:masterClrMapping/>
+  </p:clrMapOvr>
+</p:sld>
+</file>
+
+<file path=ppt/slides/slide10.xml><?xml version="1.0" encoding="utf-8"?>
+<p:sld xmlns:a="http://schemas.openxmlformats.org/drawingml/2006/main" xmlns:p="http://schemas.openxmlformats.org/presentationml/2006/main" xmlns:r="http://schemas.openxmlformats.org/officeDocument/2006/relationships">
+  <p:cSld>
+    <p:spTree>
+      <p:nvGrpSpPr>
+        <p:cNvPr id="1" name=""/>
+        <p:cNvGrpSpPr/>
+        <p:nvPr/>
+      </p:nvGrpSpPr>
+      <p:grpSpPr/>
+      <p:sp>
+        <p:nvSpPr>
+          <p:cNvPr id="2" name="Title 1"/>
+          <p:cNvSpPr>
+            <a:spLocks noGrp="1"/>
+          </p:cNvSpPr>
+          <p:nvPr>
+            <p:ph type="title"/>
+          </p:nvPr>
+        </p:nvSpPr>
+        <p:spPr/>
+        <p:txBody>
+          <a:bodyPr/>
+          <a:lstStyle/>
+          <a:p>
+            <a:r>
+              <a:t>GenAI and the Enterprise</a:t>
+            </a:r>
+          </a:p>
+        </p:txBody>
+      </p:sp>
+      <p:sp>
+        <p:nvSpPr>
+          <p:cNvPr id="3" name="Content Placeholder 2"/>
+          <p:cNvSpPr>
+            <a:spLocks noGrp="1"/>
+          </p:cNvSpPr>
+          <p:nvPr>
+            <p:ph idx="1"/>
+          </p:nvPr>
+        </p:nvSpPr>
+        <p:spPr/>
+        <p:txBody>
+          <a:bodyPr/>
+          <a:lstStyle/>
+          <a:p>
+            <a:pPr>
+              <a:defRPr sz="2000"/>
+            </a:pPr>
+            <a:r>
+              <a:t>Integrating GenAI into existing workflows</a:t>
+            </a:r>
+          </a:p>
+          <a:p>
+            <a:pPr>
+              <a:defRPr sz="2000"/>
+            </a:pPr>
+            <a:r>
+              <a:t>Choosing the right GenAI solutions</a:t>
+            </a:r>
+          </a:p>
+          <a:p>
+            <a:pPr>
+              <a:defRPr sz="2000"/>
+            </a:pPr>
+            <a:r>
+              <a:t>Training and upskilling employees</a:t>
+            </a:r>
+          </a:p>
+        </p:txBody>
+      </p:sp>
+    </p:spTree>
+  </p:cSld>
+  <p:clrMapOvr>
+    <a:masterClrMapping/>
+  </p:clrMapOvr>
+</p:sld>
+</file>
+
+<file path=ppt/slides/slide11.xml><?xml version="1.0" encoding="utf-8"?>
+<p:sld xmlns:a="http://schemas.openxmlformats.org/drawingml/2006/main" xmlns:p="http://schemas.openxmlformats.org/presentationml/2006/main" xmlns:r="http://schemas.openxmlformats.org/officeDocument/2006/relationships">
+  <p:cSld>
+    <p:spTree>
+      <p:nvGrpSpPr>
+        <p:cNvPr id="1" name=""/>
+        <p:cNvGrpSpPr/>
+        <p:nvPr/>
+      </p:nvGrpSpPr>
+      <p:grpSpPr/>
+      <p:sp>
+        <p:nvSpPr>
+          <p:cNvPr id="2" name="Title 1"/>
+          <p:cNvSpPr>
+            <a:spLocks noGrp="1"/>
+          </p:cNvSpPr>
+          <p:nvPr>
+            <p:ph type="title"/>
+          </p:nvPr>
+        </p:nvSpPr>
+        <p:spPr/>
+        <p:txBody>
+          <a:bodyPr/>
+          <a:lstStyle/>
+          <a:p>
+            <a:r>
+              <a:t>Getting Started with GenAI</a:t>
+            </a:r>
+          </a:p>
+        </p:txBody>
+      </p:sp>
+      <p:sp>
+        <p:nvSpPr>
+          <p:cNvPr id="3" name="Content Placeholder 2"/>
+          <p:cNvSpPr>
+            <a:spLocks noGrp="1"/>
+          </p:cNvSpPr>
+          <p:nvPr>
+            <p:ph idx="1"/>
+          </p:nvPr>
+        </p:nvSpPr>
+        <p:spPr/>
+        <p:txBody>
+          <a:bodyPr/>
+          <a:lstStyle/>
+          <a:p>
+            <a:pPr>
+              <a:defRPr sz="2000"/>
+            </a:pPr>
+            <a:r>
+              <a:t>Available platforms and tools</a:t>
+            </a:r>
+          </a:p>
+          <a:p>
+            <a:pPr>
+              <a:defRPr sz="2000"/>
+            </a:pPr>
+            <a:r>
+              <a:t>Open-source resources and communities</a:t>
+            </a:r>
+          </a:p>
+          <a:p>
+            <a:pPr>
+              <a:defRPr sz="2000"/>
+            </a:pPr>
+            <a:r>
+              <a:t>Learning resources and tutorials</a:t>
+            </a:r>
+          </a:p>
+        </p:txBody>
+      </p:sp>
+    </p:spTree>
+  </p:cSld>
+  <p:clrMapOvr>
+    <a:masterClrMapping/>
+  </p:clrMapOvr>
+</p:sld>
+</file>
+
+<file path=ppt/slides/slide12.xml><?xml version="1.0" encoding="utf-8"?>
+<p:sld xmlns:a="http://schemas.openxmlformats.org/drawingml/2006/main" xmlns:p="http://schemas.openxmlformats.org/presentationml/2006/main" xmlns:r="http://schemas.openxmlformats.org/officeDocument/2006/relationships">
+  <p:cSld>
+    <p:spTree>
+      <p:nvGrpSpPr>
+        <p:cNvPr id="1" name=""/>
+        <p:cNvGrpSpPr/>
+        <p:nvPr/>
+      </p:nvGrpSpPr>
+      <p:grpSpPr/>
+      <p:sp>
+        <p:nvSpPr>
+          <p:cNvPr id="2" name="Title 1"/>
+          <p:cNvSpPr>
+            <a:spLocks noGrp="1"/>
+          </p:cNvSpPr>
+          <p:nvPr>
+            <p:ph type="title"/>
+          </p:nvPr>
+        </p:nvSpPr>
+        <p:spPr/>
+        <p:txBody>
+          <a:bodyPr/>
+          <a:lstStyle/>
+          <a:p>
+            <a:r>
+              <a:t>Examples of Successful GenAI Implementations</a:t>
+            </a:r>
+          </a:p>
+        </p:txBody>
+      </p:sp>
+      <p:sp>
+        <p:nvSpPr>
+          <p:cNvPr id="3" name="Content Placeholder 2"/>
+          <p:cNvSpPr>
+            <a:spLocks noGrp="1"/>
+          </p:cNvSpPr>
+          <p:nvPr>
+            <p:ph idx="1"/>
+          </p:nvPr>
+        </p:nvSpPr>
+        <p:spPr/>
+        <p:txBody>
+          <a:bodyPr/>
+          <a:lstStyle/>
+          <a:p>
+            <a:pPr>
+              <a:defRPr sz="2000"/>
+            </a:pPr>
+            <a:r>
+              <a:t>Case Study 1: Company X</a:t>
+            </a:r>
+          </a:p>
+          <a:p>
+            <a:pPr>
+              <a:defRPr sz="2000"/>
+            </a:pPr>
+            <a:r>
+              <a:t>Case Study 2: Organization Y</a:t>
+            </a:r>
+          </a:p>
+          <a:p>
+            <a:pPr>
+              <a:defRPr sz="2000"/>
+            </a:pPr>
+            <a:r>
+              <a:t>Key takeaways from real-world examples</a:t>
+            </a:r>
+          </a:p>
+        </p:txBody>
+      </p:sp>
+    </p:spTree>
+  </p:cSld>
+  <p:clrMapOvr>
+    <a:masterClrMapping/>
+  </p:clrMapOvr>
+</p:sld>
+</file>
+
+<file path=ppt/slides/slide13.xml><?xml version="1.0" encoding="utf-8"?>
+<p:sld xmlns:a="http://schemas.openxmlformats.org/drawingml/2006/main" xmlns:p="http://schemas.openxmlformats.org/presentationml/2006/main" xmlns:r="http://schemas.openxmlformats.org/officeDocument/2006/relationships">
+  <p:cSld>
+    <p:spTree>
+      <p:nvGrpSpPr>
+        <p:cNvPr id="1" name=""/>
+        <p:cNvGrpSpPr/>
+        <p:nvPr/>
+      </p:nvGrpSpPr>
+      <p:grpSpPr/>
+      <p:sp>
+        <p:nvSpPr>
+          <p:cNvPr id="2" name="Title 1"/>
+          <p:cNvSpPr>
+            <a:spLocks noGrp="1"/>
+          </p:cNvSpPr>
+          <p:nvPr>
+            <p:ph type="title"/>
+          </p:nvPr>
+        </p:nvSpPr>
+        <p:spPr/>
+        <p:txBody>
+          <a:bodyPr/>
+          <a:lstStyle/>
+          <a:p>
+            <a:r>
+              <a:t>Q&amp;A and Discussion</a:t>
+            </a:r>
+          </a:p>
+        </p:txBody>
+      </p:sp>
+      <p:sp>
+        <p:nvSpPr>
+          <p:cNvPr id="3" name="Content Placeholder 2"/>
+          <p:cNvSpPr>
+            <a:spLocks noGrp="1"/>
+          </p:cNvSpPr>
+          <p:nvPr>
+            <p:ph idx="1"/>
+          </p:nvPr>
+        </p:nvSpPr>
+        <p:spPr/>
+        <p:txBody>
+          <a:bodyPr/>
+          <a:lstStyle/>
+          <a:p>
+            <a:pPr>
+              <a:defRPr sz="2000"/>
+            </a:pPr>
+            <a:r>
+              <a:t>Open forum for questions and answers</a:t>
+            </a:r>
+          </a:p>
+          <a:p>
+            <a:pPr>
+              <a:defRPr sz="2000"/>
+            </a:pPr>
+            <a:r>
+              <a:t>Discussing potential applications and concerns</a:t>
+            </a:r>
+          </a:p>
+          <a:p>
+            <a:pPr>
+              <a:defRPr sz="2000"/>
+            </a:pPr>
+            <a:r>
+              <a:t>Sharing insights and perspectives</a:t>
             </a:r>
           </a:p>
         </p:txBody>
@@ -3191,7 +3511,7 @@
           <a:lstStyle/>
           <a:p>
             <a:r>
-              <a:t>Core Technologies Behind GenAI</a:t>
+              <a:t>GenAI Models: A Landscape</a:t>
             </a:r>
           </a:p>
         </p:txBody>
@@ -3223,7 +3543,7 @@
               <a:defRPr sz="2000"/>
             </a:pPr>
             <a:r>
-              <a:t>Transformers and attention mechanisms</a:t>
+              <a:t>Diffusion Models</a:t>
             </a:r>
           </a:p>
           <a:p>
@@ -3270,7 +3590,7 @@
           <a:lstStyle/>
           <a:p>
             <a:r>
-              <a:t>Applications Across Industries</a:t>
+              <a:t>Applications of GenAI: Content Creation</a:t>
             </a:r>
           </a:p>
         </p:txBody>
@@ -3294,7 +3614,7 @@
               <a:defRPr sz="2000"/>
             </a:pPr>
             <a:r>
-              <a:t>Content creation: text, images, audio, video</a:t>
+              <a:t>Automated content generation for marketing</a:t>
             </a:r>
           </a:p>
           <a:p>
@@ -3302,7 +3622,7 @@
               <a:defRPr sz="2000"/>
             </a:pPr>
             <a:r>
-              <a:t>Drug discovery and materials science</a:t>
+              <a:t>Drafting articles and reports</a:t>
             </a:r>
           </a:p>
           <a:p>
@@ -3310,7 +3630,7 @@
               <a:defRPr sz="2000"/>
             </a:pPr>
             <a:r>
-              <a:t>Software development: code generation</a:t>
+              <a:t>Creating social media posts</a:t>
             </a:r>
           </a:p>
         </p:txBody>
@@ -3349,7 +3669,7 @@
           <a:lstStyle/>
           <a:p>
             <a:r>
-              <a:t>Benefits of Implementing GenAI</a:t>
+              <a:t>Applications of GenAI: Design &amp; Art</a:t>
             </a:r>
           </a:p>
         </p:txBody>
@@ -3373,7 +3693,7 @@
               <a:defRPr sz="2000"/>
             </a:pPr>
             <a:r>
-              <a:t>Increased efficiency and productivity</a:t>
+              <a:t>Generating images from text prompts</a:t>
             </a:r>
           </a:p>
           <a:p>
@@ -3381,7 +3701,7 @@
               <a:defRPr sz="2000"/>
             </a:pPr>
             <a:r>
-              <a:t>Reduced costs and improved ROI</a:t>
+              <a:t>Creating unique designs and patterns</a:t>
             </a:r>
           </a:p>
           <a:p>
@@ -3389,7 +3709,7 @@
               <a:defRPr sz="2000"/>
             </a:pPr>
             <a:r>
-              <a:t>Enhanced creativity and innovation</a:t>
+              <a:t>Assisting artists with creative workflows</a:t>
             </a:r>
           </a:p>
         </p:txBody>
@@ -3428,7 +3748,7 @@
           <a:lstStyle/>
           <a:p>
             <a:r>
-              <a:t>Challenges and Limitations</a:t>
+              <a:t>Applications of GenAI: Code Generation</a:t>
             </a:r>
           </a:p>
         </p:txBody>
@@ -3452,7 +3772,7 @@
               <a:defRPr sz="2000"/>
             </a:pPr>
             <a:r>
-              <a:t>Bias and ethical considerations</a:t>
+              <a:t>Automated code completion and generation</a:t>
             </a:r>
           </a:p>
           <a:p>
@@ -3460,7 +3780,7 @@
               <a:defRPr sz="2000"/>
             </a:pPr>
             <a:r>
-              <a:t>Data privacy and security risks</a:t>
+              <a:t>Assisting developers with debugging</a:t>
             </a:r>
           </a:p>
           <a:p>
@@ -3468,7 +3788,7 @@
               <a:defRPr sz="2000"/>
             </a:pPr>
             <a:r>
-              <a:t>Hallucinations and factual inaccuracies</a:t>
+              <a:t>Generating code from natural language</a:t>
             </a:r>
           </a:p>
         </p:txBody>
@@ -3507,7 +3827,7 @@
           <a:lstStyle/>
           <a:p>
             <a:r>
-              <a:t>Ethical Considerations</a:t>
+              <a:t>Applications of GenAI: Data Augmentation</a:t>
             </a:r>
           </a:p>
         </p:txBody>
@@ -3531,7 +3851,7 @@
               <a:defRPr sz="2000"/>
             </a:pPr>
             <a:r>
-              <a:t>Transparency and explainability</a:t>
+              <a:t>Creating synthetic data for training models</a:t>
             </a:r>
           </a:p>
           <a:p>
@@ -3539,7 +3859,7 @@
               <a:defRPr sz="2000"/>
             </a:pPr>
             <a:r>
-              <a:t>Fairness and avoiding discrimination</a:t>
+              <a:t>Addressing data scarcity issues</a:t>
             </a:r>
           </a:p>
           <a:p>
@@ -3547,7 +3867,7 @@
               <a:defRPr sz="2000"/>
             </a:pPr>
             <a:r>
-              <a:t>Responsible AI development and deployment</a:t>
+              <a:t>Improving model robustness</a:t>
             </a:r>
           </a:p>
         </p:txBody>
@@ -3586,7 +3906,7 @@
           <a:lstStyle/>
           <a:p>
             <a:r>
-              <a:t>The Future of GenAI</a:t>
+              <a:t>Benefits of GenAI</a:t>
             </a:r>
           </a:p>
         </p:txBody>
@@ -3610,7 +3930,7 @@
               <a:defRPr sz="2000"/>
             </a:pPr>
             <a:r>
-              <a:t>Continued advancements in model capabilities</a:t>
+              <a:t>Increased efficiency and productivity</a:t>
             </a:r>
           </a:p>
           <a:p>
@@ -3618,7 +3938,7 @@
               <a:defRPr sz="2000"/>
             </a:pPr>
             <a:r>
-              <a:t>Integration with other technologies</a:t>
+              <a:t>Reduced costs and faster turnaround times</a:t>
             </a:r>
           </a:p>
           <a:p>
@@ -3626,7 +3946,7 @@
               <a:defRPr sz="2000"/>
             </a:pPr>
             <a:r>
-              <a:t>Transformative impact on society</a:t>
+              <a:t>Enhanced creativity and innovation</a:t>
             </a:r>
           </a:p>
         </p:txBody>
@@ -3665,7 +3985,7 @@
           <a:lstStyle/>
           <a:p>
             <a:r>
-              <a:t>GenAI Use Cases: Content Creation</a:t>
+              <a:t>Challenges of GenAI</a:t>
             </a:r>
           </a:p>
         </p:txBody>
@@ -3689,7 +4009,7 @@
               <a:defRPr sz="2000"/>
             </a:pPr>
             <a:r>
-              <a:t>Automated article writing</a:t>
+              <a:t>Bias and fairness concerns</a:t>
             </a:r>
           </a:p>
           <a:p>
@@ -3697,7 +4017,7 @@
               <a:defRPr sz="2000"/>
             </a:pPr>
             <a:r>
-              <a:t>Social media content generation</a:t>
+              <a:t>Ethical considerations and misuse potential</a:t>
             </a:r>
           </a:p>
           <a:p>
@@ -3705,7 +4025,7 @@
               <a:defRPr sz="2000"/>
             </a:pPr>
             <a:r>
-              <a:t>Creative writing and storytelling</a:t>
+              <a:t>Computational resources and energy consumption</a:t>
             </a:r>
           </a:p>
         </p:txBody>
@@ -3744,7 +4064,7 @@
           <a:lstStyle/>
           <a:p>
             <a:r>
-              <a:t>GenAI Use Cases: Business Applications</a:t>
+              <a:t>The Future of GenAI</a:t>
             </a:r>
           </a:p>
         </p:txBody>
@@ -3768,7 +4088,7 @@
               <a:defRPr sz="2000"/>
             </a:pPr>
             <a:r>
-              <a:t>Customer service chatbots</a:t>
+              <a:t>Emerging trends and research areas</a:t>
             </a:r>
           </a:p>
           <a:p>
@@ -3776,7 +4096,7 @@
               <a:defRPr sz="2000"/>
             </a:pPr>
             <a:r>
-              <a:t>Marketing campaign optimization</a:t>
+              <a:t>Potential impact on various industries</a:t>
             </a:r>
           </a:p>
           <a:p>
@@ -3784,7 +4104,7 @@
               <a:defRPr sz="2000"/>
             </a:pPr>
             <a:r>
-              <a:t>Data analysis and insights generation</a:t>
+              <a:t>Evolving regulatory landscape</a:t>
             </a:r>
           </a:p>
         </p:txBody>

</xml_diff>

<commit_message>
Working multi ai agentic ppt generation with horde image generation
</commit_message>
<xml_diff>
--- a/services/agno_service/output.pptx
+++ b/services/agno_service/output.pptx
@@ -16,10 +16,6 @@
     <p:sldId id="264" r:id="rId15"/>
     <p:sldId id="265" r:id="rId16"/>
     <p:sldId id="266" r:id="rId17"/>
-    <p:sldId id="267" r:id="rId18"/>
-    <p:sldId id="268" r:id="rId19"/>
-    <p:sldId id="269" r:id="rId20"/>
-    <p:sldId id="270" r:id="rId21"/>
   </p:sldIdLst>
   <p:sldSz cx="12188952" cy="6858000" type="screen4x3"/>
   <p:notesSz cx="6858000" cy="9144000"/>
@@ -3137,7 +3133,7 @@
                 </a:solidFill>
                 <a:latin typeface="Arial"/>
               </a:rPr>
-              <a:t>Cybersecurity Landscape: Navigating Evolving Threats</a:t>
+              <a:t>Azure AKS: Accelerating Cloud-Native Development</a:t>
             </a:r>
           </a:p>
         </p:txBody>
@@ -3179,7 +3175,7 @@
                 </a:solidFill>
                 <a:latin typeface="Arial"/>
               </a:rPr>
-              <a:t>A comprehensive overview of current and emerging cyber threats.</a:t>
+              <a:t>Empowering modern application strategies for agility.</a:t>
             </a:r>
           </a:p>
           <a:p>
@@ -3198,7 +3194,7 @@
                 </a:solidFill>
                 <a:latin typeface="Arial"/>
               </a:rPr>
-              <a:t>Strategic approaches to building robust cyber resilience.</a:t>
+              <a:t>Driving scalability and operational efficiency in the cloud.</a:t>
             </a:r>
           </a:p>
         </p:txBody>
@@ -3280,7 +3276,7 @@
                 </a:solidFill>
                 <a:latin typeface="Arial"/>
               </a:rPr>
-              <a:t>Process: Effective Incident Response Lifecycle</a:t>
+              <a:t>Strategic Action Plan for AKS Adoption</a:t>
             </a:r>
           </a:p>
         </p:txBody>
@@ -3322,7 +3318,7 @@
                 </a:solidFill>
                 <a:latin typeface="Arial"/>
               </a:rPr>
-              <a:t>Phases: Preparation, identification, containment, eradication, recovery, and post-incident review are critical.</a:t>
+              <a:t>**Phase 1: Assessment &amp; Pilot:** Evaluate current applications, define use cases.</a:t>
             </a:r>
           </a:p>
           <a:p>
@@ -3341,7 +3337,7 @@
                 </a:solidFill>
                 <a:latin typeface="Arial"/>
               </a:rPr>
-              <a:t>Coordination: Requires cross-functional collaboration, clear communication protocols, and defined roles.</a:t>
+              <a:t>**Phase 2: Design &amp; Build:** Architect AKS environment, establish CI/CD pipelines.</a:t>
             </a:r>
           </a:p>
           <a:p>
@@ -3360,7 +3356,7 @@
                 </a:solidFill>
                 <a:latin typeface="Arial"/>
               </a:rPr>
-              <a:t>Goal: Minimize impact, restore operations swiftly, and prevent future occurrences through continuous learning.</a:t>
+              <a:t>**Phase 3: Migrate &amp; Optimize:** Transition applications, fine-tune performance and costs.</a:t>
             </a:r>
           </a:p>
           <a:p>
@@ -3379,14 +3375,347 @@
                 </a:solidFill>
                 <a:latin typeface="Arial"/>
               </a:rPr>
-              <a:t>Readiness: Regular drills and tabletop exercises are essential to maintain response readiness.</a:t>
+              <a:t>**Phase 4: Govern &amp; Scale:** Implement policies, expand AKS usage across the organization.</a:t>
+            </a:r>
+          </a:p>
+        </p:txBody>
+      </p:sp>
+    </p:spTree>
+  </p:cSld>
+  <p:clrMapOvr>
+    <a:masterClrMapping/>
+  </p:clrMapOvr>
+</p:sld>
+</file>
+
+<file path=ppt/slides/slide11.xml><?xml version="1.0" encoding="utf-8"?>
+<p:sld xmlns:a="http://schemas.openxmlformats.org/drawingml/2006/main" xmlns:p="http://schemas.openxmlformats.org/presentationml/2006/main" xmlns:r="http://schemas.openxmlformats.org/officeDocument/2006/relationships">
+  <p:cSld>
+    <p:spTree>
+      <p:nvGrpSpPr>
+        <p:cNvPr id="1" name=""/>
+        <p:cNvGrpSpPr/>
+        <p:nvPr/>
+      </p:nvGrpSpPr>
+      <p:grpSpPr/>
+      <p:sp>
+        <p:nvSpPr>
+          <p:cNvPr id="2" name="Title 1"/>
+          <p:cNvSpPr>
+            <a:spLocks noGrp="1"/>
+          </p:cNvSpPr>
+          <p:nvPr>
+            <p:ph type="title"/>
+          </p:nvPr>
+        </p:nvSpPr>
+        <p:spPr>
+          <a:xfrm>
+            <a:off x="571500" y="571500"/>
+            <a:ext cx="11045952" cy="914400"/>
+          </a:xfrm>
+        </p:spPr>
+        <p:txBody>
+          <a:bodyPr/>
+          <a:lstStyle/>
+          <a:p>
+            <a:pPr algn="ctr">
+              <a:defRPr sz="2800" b="1">
+                <a:solidFill>
+                  <a:srgbClr val="111111"/>
+                </a:solidFill>
+                <a:latin typeface="Arial"/>
+              </a:defRPr>
+            </a:pPr>
+            <a:r>
+              <a:rPr sz="2800" b="1">
+                <a:solidFill>
+                  <a:srgbClr val="111111"/>
+                </a:solidFill>
+                <a:latin typeface="Arial"/>
+              </a:rPr>
+              <a:t>Appendix: Glossary of Key Terms</a:t>
+            </a:r>
+          </a:p>
+        </p:txBody>
+      </p:sp>
+      <p:sp>
+        <p:nvSpPr>
+          <p:cNvPr id="3" name="Content Placeholder 2"/>
+          <p:cNvSpPr>
+            <a:spLocks noGrp="1"/>
+          </p:cNvSpPr>
+          <p:nvPr>
+            <p:ph idx="1"/>
+          </p:nvPr>
+        </p:nvSpPr>
+        <p:spPr>
+          <a:xfrm>
+            <a:off x="571500" y="1557337"/>
+            <a:ext cx="6133315" cy="4729162"/>
+          </a:xfrm>
+        </p:spPr>
+        <p:txBody>
+          <a:bodyPr wrap="square">
+            <a:noAutofit/>
+          </a:bodyPr>
+          <a:lstStyle/>
+          <a:p>
+            <a:pPr algn="l">
+              <a:defRPr sz="1600">
+                <a:solidFill>
+                  <a:srgbClr val="111111"/>
+                </a:solidFill>
+                <a:latin typeface="Arial"/>
+              </a:defRPr>
+            </a:pPr>
+            <a:r>
+              <a:rPr sz="1600">
+                <a:solidFill>
+                  <a:srgbClr val="111111"/>
+                </a:solidFill>
+                <a:latin typeface="Arial"/>
+              </a:rPr>
+              <a:t>**Kubernetes:** Open-source system for automating deployment, scaling, and management of containerized applications.</a:t>
+            </a:r>
+          </a:p>
+          <a:p>
+            <a:pPr algn="l">
+              <a:defRPr sz="1600">
+                <a:solidFill>
+                  <a:srgbClr val="111111"/>
+                </a:solidFill>
+                <a:latin typeface="Arial"/>
+              </a:defRPr>
+            </a:pPr>
+            <a:r>
+              <a:rPr sz="1600">
+                <a:solidFill>
+                  <a:srgbClr val="111111"/>
+                </a:solidFill>
+                <a:latin typeface="Arial"/>
+              </a:rPr>
+              <a:t>**Container:** Lightweight, portable, executable software package that includes everything needed to run it.</a:t>
+            </a:r>
+          </a:p>
+          <a:p>
+            <a:pPr algn="l">
+              <a:defRPr sz="1600">
+                <a:solidFill>
+                  <a:srgbClr val="111111"/>
+                </a:solidFill>
+                <a:latin typeface="Arial"/>
+              </a:defRPr>
+            </a:pPr>
+            <a:r>
+              <a:rPr sz="1600">
+                <a:solidFill>
+                  <a:srgbClr val="111111"/>
+                </a:solidFill>
+                <a:latin typeface="Arial"/>
+              </a:rPr>
+              <a:t>**Pod:** The smallest deployable unit in Kubernetes, representing a single instance of a running process.</a:t>
+            </a:r>
+          </a:p>
+          <a:p>
+            <a:pPr algn="l">
+              <a:defRPr sz="1600">
+                <a:solidFill>
+                  <a:srgbClr val="111111"/>
+                </a:solidFill>
+                <a:latin typeface="Arial"/>
+              </a:defRPr>
+            </a:pPr>
+            <a:r>
+              <a:rPr sz="1600">
+                <a:solidFill>
+                  <a:srgbClr val="111111"/>
+                </a:solidFill>
+                <a:latin typeface="Arial"/>
+              </a:rPr>
+              <a:t>**Node:** A worker machine in a Kubernetes cluster, which runs containerized applications.</a:t>
+            </a:r>
+          </a:p>
+          <a:p>
+            <a:pPr algn="l">
+              <a:defRPr sz="1600">
+                <a:solidFill>
+                  <a:srgbClr val="111111"/>
+                </a:solidFill>
+                <a:latin typeface="Arial"/>
+              </a:defRPr>
+            </a:pPr>
+            <a:r>
+              <a:rPr sz="1600">
+                <a:solidFill>
+                  <a:srgbClr val="111111"/>
+                </a:solidFill>
+                <a:latin typeface="Arial"/>
+              </a:rPr>
+              <a:t>**Deployment:** A Kubernetes object that manages a set of identical Pods, ensuring a desired state.</a:t>
+            </a:r>
+          </a:p>
+        </p:txBody>
+      </p:sp>
+    </p:spTree>
+  </p:cSld>
+  <p:clrMapOvr>
+    <a:masterClrMapping/>
+  </p:clrMapOvr>
+</p:sld>
+</file>
+
+<file path=ppt/slides/slide2.xml><?xml version="1.0" encoding="utf-8"?>
+<p:sld xmlns:a="http://schemas.openxmlformats.org/drawingml/2006/main" xmlns:p="http://schemas.openxmlformats.org/presentationml/2006/main" xmlns:r="http://schemas.openxmlformats.org/officeDocument/2006/relationships">
+  <p:cSld>
+    <p:spTree>
+      <p:nvGrpSpPr>
+        <p:cNvPr id="1" name=""/>
+        <p:cNvGrpSpPr/>
+        <p:nvPr/>
+      </p:nvGrpSpPr>
+      <p:grpSpPr/>
+      <p:sp>
+        <p:nvSpPr>
+          <p:cNvPr id="2" name="Title 1"/>
+          <p:cNvSpPr>
+            <a:spLocks noGrp="1"/>
+          </p:cNvSpPr>
+          <p:nvPr>
+            <p:ph type="title"/>
+          </p:nvPr>
+        </p:nvSpPr>
+        <p:spPr>
+          <a:xfrm>
+            <a:off x="571500" y="571500"/>
+            <a:ext cx="11045952" cy="914400"/>
+          </a:xfrm>
+        </p:spPr>
+        <p:txBody>
+          <a:bodyPr/>
+          <a:lstStyle/>
+          <a:p>
+            <a:pPr algn="ctr">
+              <a:defRPr sz="2800" b="1">
+                <a:solidFill>
+                  <a:srgbClr val="111111"/>
+                </a:solidFill>
+                <a:latin typeface="Arial"/>
+              </a:defRPr>
+            </a:pPr>
+            <a:r>
+              <a:rPr sz="2800" b="1">
+                <a:solidFill>
+                  <a:srgbClr val="111111"/>
+                </a:solidFill>
+                <a:latin typeface="Arial"/>
+              </a:rPr>
+              <a:t>Executive Summary: Unlocking Business Agility with AKS</a:t>
+            </a:r>
+          </a:p>
+        </p:txBody>
+      </p:sp>
+      <p:sp>
+        <p:nvSpPr>
+          <p:cNvPr id="3" name="Content Placeholder 2"/>
+          <p:cNvSpPr>
+            <a:spLocks noGrp="1"/>
+          </p:cNvSpPr>
+          <p:nvPr>
+            <p:ph idx="1"/>
+          </p:nvPr>
+        </p:nvSpPr>
+        <p:spPr>
+          <a:xfrm>
+            <a:off x="571500" y="1557337"/>
+            <a:ext cx="6133315" cy="4729162"/>
+          </a:xfrm>
+        </p:spPr>
+        <p:txBody>
+          <a:bodyPr wrap="square">
+            <a:noAutofit/>
+          </a:bodyPr>
+          <a:lstStyle/>
+          <a:p>
+            <a:pPr algn="l">
+              <a:defRPr sz="1600">
+                <a:solidFill>
+                  <a:srgbClr val="111111"/>
+                </a:solidFill>
+                <a:latin typeface="Arial"/>
+              </a:defRPr>
+            </a:pPr>
+            <a:r>
+              <a:rPr sz="1600">
+                <a:solidFill>
+                  <a:srgbClr val="111111"/>
+                </a:solidFill>
+                <a:latin typeface="Arial"/>
+              </a:rPr>
+              <a:t>**Situation:** Businesses demand rapid, scalable application deployment.</a:t>
+            </a:r>
+          </a:p>
+          <a:p>
+            <a:pPr algn="l">
+              <a:defRPr sz="1600">
+                <a:solidFill>
+                  <a:srgbClr val="111111"/>
+                </a:solidFill>
+                <a:latin typeface="Arial"/>
+              </a:defRPr>
+            </a:pPr>
+            <a:r>
+              <a:rPr sz="1600">
+                <a:solidFill>
+                  <a:srgbClr val="111111"/>
+                </a:solidFill>
+                <a:latin typeface="Arial"/>
+              </a:rPr>
+              <a:t>**Complication:** Managing complex container orchestration is resource-intensive.</a:t>
+            </a:r>
+          </a:p>
+          <a:p>
+            <a:pPr algn="l">
+              <a:defRPr sz="1600">
+                <a:solidFill>
+                  <a:srgbClr val="111111"/>
+                </a:solidFill>
+                <a:latin typeface="Arial"/>
+              </a:defRPr>
+            </a:pPr>
+            <a:r>
+              <a:rPr sz="1600">
+                <a:solidFill>
+                  <a:srgbClr val="111111"/>
+                </a:solidFill>
+                <a:latin typeface="Arial"/>
+              </a:rPr>
+              <a:t>**Question:** How can organizations simplify operations and accelerate innovation?</a:t>
+            </a:r>
+          </a:p>
+          <a:p>
+            <a:pPr algn="l">
+              <a:defRPr sz="1600">
+                <a:solidFill>
+                  <a:srgbClr val="111111"/>
+                </a:solidFill>
+                <a:latin typeface="Arial"/>
+              </a:defRPr>
+            </a:pPr>
+            <a:r>
+              <a:rPr sz="1600">
+                <a:solidFill>
+                  <a:srgbClr val="111111"/>
+                </a:solidFill>
+                <a:latin typeface="Arial"/>
+              </a:rPr>
+              <a:t>**Answer:** Azure AKS offers a managed, secure, and scalable platform for modern applications.</a:t>
             </a:r>
           </a:p>
         </p:txBody>
       </p:sp>
       <p:pic>
         <p:nvPicPr>
-          <p:cNvPr id="4" name="Picture 3" descr="slide_0_0.png"/>
+          <p:cNvPr id="4" name="Picture 3" descr="slide_2_1.png"/>
           <p:cNvPicPr>
             <a:picLocks noChangeAspect="1"/>
           </p:cNvPicPr>
@@ -3416,7 +3745,7 @@
 </p:sld>
 </file>
 
-<file path=ppt/slides/slide11.xml><?xml version="1.0" encoding="utf-8"?>
+<file path=ppt/slides/slide3.xml><?xml version="1.0" encoding="utf-8"?>
 <p:sld xmlns:a="http://schemas.openxmlformats.org/drawingml/2006/main" xmlns:p="http://schemas.openxmlformats.org/presentationml/2006/main" xmlns:r="http://schemas.openxmlformats.org/officeDocument/2006/relationships">
   <p:cSld>
     <p:spTree>
@@ -3461,7 +3790,7 @@
                 </a:solidFill>
                 <a:latin typeface="Arial"/>
               </a:rPr>
-              <a:t>Case Study: Securing a Global Enterprise with Zero Trust</a:t>
+              <a:t>Understanding Azure Kubernetes Service (AKS)</a:t>
             </a:r>
           </a:p>
         </p:txBody>
@@ -3503,7 +3832,7 @@
                 </a:solidFill>
                 <a:latin typeface="Arial"/>
               </a:rPr>
-              <a:t>Challenge: A multinational corporation faced escalating threats and struggled with legacy perimeter security.</a:t>
+              <a:t>**Definition:** AKS is a fully managed Kubernetes service on Microsoft Azure.</a:t>
             </a:r>
           </a:p>
           <a:p>
@@ -3522,7 +3851,7 @@
                 </a:solidFill>
                 <a:latin typeface="Arial"/>
               </a:rPr>
-              <a:t>Solution: Implemented a comprehensive Zero Trust model, integrating identity, device, and network controls.</a:t>
+              <a:t>Simplifies deployment, management, and scaling of containerized applications.</a:t>
             </a:r>
           </a:p>
           <a:p>
@@ -3541,7 +3870,7 @@
                 </a:solidFill>
                 <a:latin typeface="Arial"/>
               </a:rPr>
-              <a:t>Outcome: Reduced attack surface by 40%, improved compliance posture, and enhanced user experience.</a:t>
+              <a:t>Integrates seamlessly with Azure services for comprehensive solutions.</a:t>
             </a:r>
           </a:p>
           <a:p>
@@ -3560,14 +3889,14 @@
                 </a:solidFill>
                 <a:latin typeface="Arial"/>
               </a:rPr>
-              <a:t>Learning: Phased implementation and strong executive sponsorship were key to success.</a:t>
+              <a:t>Reduces operational overhead for Kubernetes cluster management.</a:t>
             </a:r>
           </a:p>
         </p:txBody>
       </p:sp>
       <p:pic>
         <p:nvPicPr>
-          <p:cNvPr id="4" name="Picture 3" descr="slide_0_0.png"/>
+          <p:cNvPr id="4" name="Picture 3" descr="slide_3_2.png"/>
           <p:cNvPicPr>
             <a:picLocks noChangeAspect="1"/>
           </p:cNvPicPr>
@@ -3597,1029 +3926,6 @@
 </p:sld>
 </file>
 
-<file path=ppt/slides/slide12.xml><?xml version="1.0" encoding="utf-8"?>
-<p:sld xmlns:a="http://schemas.openxmlformats.org/drawingml/2006/main" xmlns:p="http://schemas.openxmlformats.org/presentationml/2006/main" xmlns:r="http://schemas.openxmlformats.org/officeDocument/2006/relationships">
-  <p:cSld>
-    <p:spTree>
-      <p:nvGrpSpPr>
-        <p:cNvPr id="1" name=""/>
-        <p:cNvGrpSpPr/>
-        <p:nvPr/>
-      </p:nvGrpSpPr>
-      <p:grpSpPr/>
-      <p:sp>
-        <p:nvSpPr>
-          <p:cNvPr id="2" name="Title 1"/>
-          <p:cNvSpPr>
-            <a:spLocks noGrp="1"/>
-          </p:cNvSpPr>
-          <p:nvPr>
-            <p:ph type="title"/>
-          </p:nvPr>
-        </p:nvSpPr>
-        <p:spPr>
-          <a:xfrm>
-            <a:off x="571500" y="571500"/>
-            <a:ext cx="11045952" cy="914400"/>
-          </a:xfrm>
-        </p:spPr>
-        <p:txBody>
-          <a:bodyPr/>
-          <a:lstStyle/>
-          <a:p>
-            <a:pPr algn="ctr">
-              <a:defRPr sz="2800" b="1">
-                <a:solidFill>
-                  <a:srgbClr val="111111"/>
-                </a:solidFill>
-                <a:latin typeface="Arial"/>
-              </a:defRPr>
-            </a:pPr>
-            <a:r>
-              <a:rPr sz="2800" b="1">
-                <a:solidFill>
-                  <a:srgbClr val="111111"/>
-                </a:solidFill>
-                <a:latin typeface="Arial"/>
-              </a:rPr>
-              <a:t>Case Study: Lessons from a Supply Chain Attack</a:t>
-            </a:r>
-          </a:p>
-        </p:txBody>
-      </p:sp>
-      <p:sp>
-        <p:nvSpPr>
-          <p:cNvPr id="3" name="Content Placeholder 2"/>
-          <p:cNvSpPr>
-            <a:spLocks noGrp="1"/>
-          </p:cNvSpPr>
-          <p:nvPr>
-            <p:ph idx="1"/>
-          </p:nvPr>
-        </p:nvSpPr>
-        <p:spPr>
-          <a:xfrm>
-            <a:off x="571500" y="1557337"/>
-            <a:ext cx="6133315" cy="4729162"/>
-          </a:xfrm>
-        </p:spPr>
-        <p:txBody>
-          <a:bodyPr wrap="square">
-            <a:noAutofit/>
-          </a:bodyPr>
-          <a:lstStyle/>
-          <a:p>
-            <a:pPr algn="l">
-              <a:defRPr sz="1600">
-                <a:solidFill>
-                  <a:srgbClr val="111111"/>
-                </a:solidFill>
-                <a:latin typeface="Arial"/>
-              </a:defRPr>
-            </a:pPr>
-            <a:r>
-              <a:rPr sz="1600">
-                <a:solidFill>
-                  <a:srgbClr val="111111"/>
-                </a:solidFill>
-                <a:latin typeface="Arial"/>
-              </a:rPr>
-              <a:t>Incident: A major software vendor experienced a sophisticated supply chain compromise impacting many customers.</a:t>
-            </a:r>
-          </a:p>
-          <a:p>
-            <a:pPr algn="l">
-              <a:defRPr sz="1600">
-                <a:solidFill>
-                  <a:srgbClr val="111111"/>
-                </a:solidFill>
-                <a:latin typeface="Arial"/>
-              </a:defRPr>
-            </a:pPr>
-            <a:r>
-              <a:rPr sz="1600">
-                <a:solidFill>
-                  <a:srgbClr val="111111"/>
-                </a:solidFill>
-                <a:latin typeface="Arial"/>
-              </a:rPr>
-              <a:t>Impact: Highlighted the interconnected risks and the potential for widespread disruption across industries.</a:t>
-            </a:r>
-          </a:p>
-          <a:p>
-            <a:pPr algn="l">
-              <a:defRPr sz="1600">
-                <a:solidFill>
-                  <a:srgbClr val="111111"/>
-                </a:solidFill>
-                <a:latin typeface="Arial"/>
-              </a:defRPr>
-            </a:pPr>
-            <a:r>
-              <a:rPr sz="1600">
-                <a:solidFill>
-                  <a:srgbClr val="111111"/>
-                </a:solidFill>
-                <a:latin typeface="Arial"/>
-              </a:rPr>
-              <a:t>Learnings: Emphasized the need for robust vendor risk management and software supply chain security practices.</a:t>
-            </a:r>
-          </a:p>
-          <a:p>
-            <a:pPr algn="l">
-              <a:defRPr sz="1600">
-                <a:solidFill>
-                  <a:srgbClr val="111111"/>
-                </a:solidFill>
-                <a:latin typeface="Arial"/>
-              </a:defRPr>
-            </a:pPr>
-            <a:r>
-              <a:rPr sz="1600">
-                <a:solidFill>
-                  <a:srgbClr val="111111"/>
-                </a:solidFill>
-                <a:latin typeface="Arial"/>
-              </a:rPr>
-              <a:t>Mitigation: Enhanced code integrity checks, multi-factor authentication for developers, and network segmentation.</a:t>
-            </a:r>
-          </a:p>
-        </p:txBody>
-      </p:sp>
-      <p:pic>
-        <p:nvPicPr>
-          <p:cNvPr id="4" name="Picture 3" descr="slide_0_0.png"/>
-          <p:cNvPicPr>
-            <a:picLocks noChangeAspect="1"/>
-          </p:cNvPicPr>
-          <p:nvPr/>
-        </p:nvPicPr>
-        <p:blipFill>
-          <a:blip r:embed="rId2"/>
-          <a:stretch>
-            <a:fillRect/>
-          </a:stretch>
-        </p:blipFill>
-        <p:spPr>
-          <a:xfrm>
-            <a:off x="6990565" y="1557337"/>
-            <a:ext cx="4626886" cy="2699017"/>
-          </a:xfrm>
-          <a:prstGeom prst="rect">
-            <a:avLst/>
-          </a:prstGeom>
-        </p:spPr>
-      </p:pic>
-    </p:spTree>
-  </p:cSld>
-  <p:clrMapOvr>
-    <a:masterClrMapping/>
-  </p:clrMapOvr>
-</p:sld>
-</file>
-
-<file path=ppt/slides/slide13.xml><?xml version="1.0" encoding="utf-8"?>
-<p:sld xmlns:a="http://schemas.openxmlformats.org/drawingml/2006/main" xmlns:p="http://schemas.openxmlformats.org/presentationml/2006/main" xmlns:r="http://schemas.openxmlformats.org/officeDocument/2006/relationships">
-  <p:cSld>
-    <p:spTree>
-      <p:nvGrpSpPr>
-        <p:cNvPr id="1" name=""/>
-        <p:cNvGrpSpPr/>
-        <p:nvPr/>
-      </p:nvGrpSpPr>
-      <p:grpSpPr/>
-      <p:sp>
-        <p:nvSpPr>
-          <p:cNvPr id="2" name="Title 1"/>
-          <p:cNvSpPr>
-            <a:spLocks noGrp="1"/>
-          </p:cNvSpPr>
-          <p:nvPr>
-            <p:ph type="title"/>
-          </p:nvPr>
-        </p:nvSpPr>
-        <p:spPr>
-          <a:xfrm>
-            <a:off x="571500" y="571500"/>
-            <a:ext cx="11045952" cy="914400"/>
-          </a:xfrm>
-        </p:spPr>
-        <p:txBody>
-          <a:bodyPr/>
-          <a:lstStyle/>
-          <a:p>
-            <a:pPr algn="ctr">
-              <a:defRPr sz="2800" b="1">
-                <a:solidFill>
-                  <a:srgbClr val="111111"/>
-                </a:solidFill>
-                <a:latin typeface="Arial"/>
-              </a:defRPr>
-            </a:pPr>
-            <a:r>
-              <a:rPr sz="2800" b="1">
-                <a:solidFill>
-                  <a:srgbClr val="111111"/>
-                </a:solidFill>
-                <a:latin typeface="Arial"/>
-              </a:rPr>
-              <a:t>Action Plan: Strengthening Your Cyber Posture</a:t>
-            </a:r>
-          </a:p>
-        </p:txBody>
-      </p:sp>
-      <p:sp>
-        <p:nvSpPr>
-          <p:cNvPr id="3" name="Content Placeholder 2"/>
-          <p:cNvSpPr>
-            <a:spLocks noGrp="1"/>
-          </p:cNvSpPr>
-          <p:nvPr>
-            <p:ph idx="1"/>
-          </p:nvPr>
-        </p:nvSpPr>
-        <p:spPr>
-          <a:xfrm>
-            <a:off x="571500" y="1557337"/>
-            <a:ext cx="6133315" cy="4729162"/>
-          </a:xfrm>
-        </p:spPr>
-        <p:txBody>
-          <a:bodyPr wrap="square">
-            <a:noAutofit/>
-          </a:bodyPr>
-          <a:lstStyle/>
-          <a:p>
-            <a:pPr algn="l">
-              <a:defRPr sz="1600">
-                <a:solidFill>
-                  <a:srgbClr val="111111"/>
-                </a:solidFill>
-                <a:latin typeface="Arial"/>
-              </a:defRPr>
-            </a:pPr>
-            <a:r>
-              <a:rPr sz="1600">
-                <a:solidFill>
-                  <a:srgbClr val="111111"/>
-                </a:solidFill>
-                <a:latin typeface="Arial"/>
-              </a:rPr>
-              <a:t>Strategy: Adopt a proactive, risk-based approach to cybersecurity investments and resource allocation.</a:t>
-            </a:r>
-          </a:p>
-          <a:p>
-            <a:pPr algn="l">
-              <a:defRPr sz="1600">
-                <a:solidFill>
-                  <a:srgbClr val="111111"/>
-                </a:solidFill>
-                <a:latin typeface="Arial"/>
-              </a:defRPr>
-            </a:pPr>
-            <a:r>
-              <a:rPr sz="1600">
-                <a:solidFill>
-                  <a:srgbClr val="111111"/>
-                </a:solidFill>
-                <a:latin typeface="Arial"/>
-              </a:rPr>
-              <a:t>Technology: Implement advanced threat detection, Zero Trust, and security automation solutions.</a:t>
-            </a:r>
-          </a:p>
-          <a:p>
-            <a:pPr algn="l">
-              <a:defRPr sz="1600">
-                <a:solidFill>
-                  <a:srgbClr val="111111"/>
-                </a:solidFill>
-                <a:latin typeface="Arial"/>
-              </a:defRPr>
-            </a:pPr>
-            <a:r>
-              <a:rPr sz="1600">
-                <a:solidFill>
-                  <a:srgbClr val="111111"/>
-                </a:solidFill>
-                <a:latin typeface="Arial"/>
-              </a:rPr>
-              <a:t>People: Foster a security-aware culture through continuous training and awareness programs.</a:t>
-            </a:r>
-          </a:p>
-          <a:p>
-            <a:pPr algn="l">
-              <a:defRPr sz="1600">
-                <a:solidFill>
-                  <a:srgbClr val="111111"/>
-                </a:solidFill>
-                <a:latin typeface="Arial"/>
-              </a:defRPr>
-            </a:pPr>
-            <a:r>
-              <a:rPr sz="1600">
-                <a:solidFill>
-                  <a:srgbClr val="111111"/>
-                </a:solidFill>
-                <a:latin typeface="Arial"/>
-              </a:rPr>
-              <a:t>Process: Regularly review and update incident response plans, conducting drills and simulations.</a:t>
-            </a:r>
-          </a:p>
-          <a:p>
-            <a:pPr algn="l">
-              <a:defRPr sz="1600">
-                <a:solidFill>
-                  <a:srgbClr val="111111"/>
-                </a:solidFill>
-                <a:latin typeface="Arial"/>
-              </a:defRPr>
-            </a:pPr>
-            <a:r>
-              <a:rPr sz="1600">
-                <a:solidFill>
-                  <a:srgbClr val="111111"/>
-                </a:solidFill>
-                <a:latin typeface="Arial"/>
-              </a:rPr>
-              <a:t>Governance: Establish clear roles, responsibilities, and metrics for cybersecurity performance.</a:t>
-            </a:r>
-          </a:p>
-        </p:txBody>
-      </p:sp>
-    </p:spTree>
-  </p:cSld>
-  <p:clrMapOvr>
-    <a:masterClrMapping/>
-  </p:clrMapOvr>
-</p:sld>
-</file>
-
-<file path=ppt/slides/slide14.xml><?xml version="1.0" encoding="utf-8"?>
-<p:sld xmlns:a="http://schemas.openxmlformats.org/drawingml/2006/main" xmlns:p="http://schemas.openxmlformats.org/presentationml/2006/main" xmlns:r="http://schemas.openxmlformats.org/officeDocument/2006/relationships">
-  <p:cSld>
-    <p:spTree>
-      <p:nvGrpSpPr>
-        <p:cNvPr id="1" name=""/>
-        <p:cNvGrpSpPr/>
-        <p:nvPr/>
-      </p:nvGrpSpPr>
-      <p:grpSpPr/>
-      <p:sp>
-        <p:nvSpPr>
-          <p:cNvPr id="2" name="Title 1"/>
-          <p:cNvSpPr>
-            <a:spLocks noGrp="1"/>
-          </p:cNvSpPr>
-          <p:nvPr>
-            <p:ph type="title"/>
-          </p:nvPr>
-        </p:nvSpPr>
-        <p:spPr>
-          <a:xfrm>
-            <a:off x="571500" y="571500"/>
-            <a:ext cx="11045952" cy="914400"/>
-          </a:xfrm>
-        </p:spPr>
-        <p:txBody>
-          <a:bodyPr/>
-          <a:lstStyle/>
-          <a:p>
-            <a:pPr algn="ctr">
-              <a:defRPr sz="2800" b="1">
-                <a:solidFill>
-                  <a:srgbClr val="111111"/>
-                </a:solidFill>
-                <a:latin typeface="Arial"/>
-              </a:defRPr>
-            </a:pPr>
-            <a:r>
-              <a:rPr sz="2800" b="1">
-                <a:solidFill>
-                  <a:srgbClr val="111111"/>
-                </a:solidFill>
-                <a:latin typeface="Arial"/>
-              </a:rPr>
-              <a:t>Conclusion: Building a Resilient Digital Future</a:t>
-            </a:r>
-          </a:p>
-        </p:txBody>
-      </p:sp>
-      <p:sp>
-        <p:nvSpPr>
-          <p:cNvPr id="3" name="Content Placeholder 2"/>
-          <p:cNvSpPr>
-            <a:spLocks noGrp="1"/>
-          </p:cNvSpPr>
-          <p:nvPr>
-            <p:ph idx="1"/>
-          </p:nvPr>
-        </p:nvSpPr>
-        <p:spPr>
-          <a:xfrm>
-            <a:off x="571500" y="1557337"/>
-            <a:ext cx="6133315" cy="4729162"/>
-          </a:xfrm>
-        </p:spPr>
-        <p:txBody>
-          <a:bodyPr wrap="square">
-            <a:noAutofit/>
-          </a:bodyPr>
-          <a:lstStyle/>
-          <a:p>
-            <a:pPr algn="l">
-              <a:defRPr sz="1600">
-                <a:solidFill>
-                  <a:srgbClr val="111111"/>
-                </a:solidFill>
-                <a:latin typeface="Arial"/>
-              </a:defRPr>
-            </a:pPr>
-            <a:r>
-              <a:rPr sz="1600">
-                <a:solidFill>
-                  <a:srgbClr val="111111"/>
-                </a:solidFill>
-                <a:latin typeface="Arial"/>
-              </a:rPr>
-              <a:t>Imperative: Cybersecurity is a continuous journey, not a static destination, requiring constant adaptation.</a:t>
-            </a:r>
-          </a:p>
-          <a:p>
-            <a:pPr algn="l">
-              <a:defRPr sz="1600">
-                <a:solidFill>
-                  <a:srgbClr val="111111"/>
-                </a:solidFill>
-                <a:latin typeface="Arial"/>
-              </a:defRPr>
-            </a:pPr>
-            <a:r>
-              <a:rPr sz="1600">
-                <a:solidFill>
-                  <a:srgbClr val="111111"/>
-                </a:solidFill>
-                <a:latin typeface="Arial"/>
-              </a:rPr>
-              <a:t>Resilience: Focus on building adaptive defenses and rapid recovery capabilities to minimize disruption.</a:t>
-            </a:r>
-          </a:p>
-          <a:p>
-            <a:pPr algn="l">
-              <a:defRPr sz="1600">
-                <a:solidFill>
-                  <a:srgbClr val="111111"/>
-                </a:solidFill>
-                <a:latin typeface="Arial"/>
-              </a:defRPr>
-            </a:pPr>
-            <a:r>
-              <a:rPr sz="1600">
-                <a:solidFill>
-                  <a:srgbClr val="111111"/>
-                </a:solidFill>
-                <a:latin typeface="Arial"/>
-              </a:rPr>
-              <a:t>Partnership: Collaboration across industries and with government agencies is key to navigating complex threats.</a:t>
-            </a:r>
-          </a:p>
-          <a:p>
-            <a:pPr algn="l">
-              <a:defRPr sz="1600">
-                <a:solidFill>
-                  <a:srgbClr val="111111"/>
-                </a:solidFill>
-                <a:latin typeface="Arial"/>
-              </a:defRPr>
-            </a:pPr>
-            <a:r>
-              <a:rPr sz="1600">
-                <a:solidFill>
-                  <a:srgbClr val="111111"/>
-                </a:solidFill>
-                <a:latin typeface="Arial"/>
-              </a:rPr>
-              <a:t>Commitment: A strong cybersecurity posture is fundamental to business continuity and trust in the digital age.</a:t>
-            </a:r>
-          </a:p>
-        </p:txBody>
-      </p:sp>
-    </p:spTree>
-  </p:cSld>
-  <p:clrMapOvr>
-    <a:masterClrMapping/>
-  </p:clrMapOvr>
-</p:sld>
-</file>
-
-<file path=ppt/slides/slide15.xml><?xml version="1.0" encoding="utf-8"?>
-<p:sld xmlns:a="http://schemas.openxmlformats.org/drawingml/2006/main" xmlns:p="http://schemas.openxmlformats.org/presentationml/2006/main" xmlns:r="http://schemas.openxmlformats.org/officeDocument/2006/relationships">
-  <p:cSld>
-    <p:spTree>
-      <p:nvGrpSpPr>
-        <p:cNvPr id="1" name=""/>
-        <p:cNvGrpSpPr/>
-        <p:nvPr/>
-      </p:nvGrpSpPr>
-      <p:grpSpPr/>
-      <p:sp>
-        <p:nvSpPr>
-          <p:cNvPr id="2" name="Title 1"/>
-          <p:cNvSpPr>
-            <a:spLocks noGrp="1"/>
-          </p:cNvSpPr>
-          <p:nvPr>
-            <p:ph type="title"/>
-          </p:nvPr>
-        </p:nvSpPr>
-        <p:spPr>
-          <a:xfrm>
-            <a:off x="571500" y="571500"/>
-            <a:ext cx="11045952" cy="914400"/>
-          </a:xfrm>
-        </p:spPr>
-        <p:txBody>
-          <a:bodyPr/>
-          <a:lstStyle/>
-          <a:p>
-            <a:pPr algn="ctr">
-              <a:defRPr sz="2800" b="1">
-                <a:solidFill>
-                  <a:srgbClr val="111111"/>
-                </a:solidFill>
-                <a:latin typeface="Arial"/>
-              </a:defRPr>
-            </a:pPr>
-            <a:r>
-              <a:rPr sz="2800" b="1">
-                <a:solidFill>
-                  <a:srgbClr val="111111"/>
-                </a:solidFill>
-                <a:latin typeface="Arial"/>
-              </a:rPr>
-              <a:t>Appendix: Glossary of Key Terms</a:t>
-            </a:r>
-          </a:p>
-        </p:txBody>
-      </p:sp>
-      <p:sp>
-        <p:nvSpPr>
-          <p:cNvPr id="3" name="Content Placeholder 2"/>
-          <p:cNvSpPr>
-            <a:spLocks noGrp="1"/>
-          </p:cNvSpPr>
-          <p:nvPr>
-            <p:ph idx="1"/>
-          </p:nvPr>
-        </p:nvSpPr>
-        <p:spPr>
-          <a:xfrm>
-            <a:off x="571500" y="1557337"/>
-            <a:ext cx="6133315" cy="4729162"/>
-          </a:xfrm>
-        </p:spPr>
-        <p:txBody>
-          <a:bodyPr wrap="square">
-            <a:noAutofit/>
-          </a:bodyPr>
-          <a:lstStyle/>
-          <a:p>
-            <a:pPr algn="l">
-              <a:defRPr sz="1600">
-                <a:solidFill>
-                  <a:srgbClr val="111111"/>
-                </a:solidFill>
-                <a:latin typeface="Arial"/>
-              </a:defRPr>
-            </a:pPr>
-            <a:r>
-              <a:rPr sz="1600">
-                <a:solidFill>
-                  <a:srgbClr val="111111"/>
-                </a:solidFill>
-                <a:latin typeface="Arial"/>
-              </a:rPr>
-              <a:t>Zero Trust: Security model assuming no implicit trust, verifying every access request.</a:t>
-            </a:r>
-          </a:p>
-          <a:p>
-            <a:pPr algn="l">
-              <a:defRPr sz="1600">
-                <a:solidFill>
-                  <a:srgbClr val="111111"/>
-                </a:solidFill>
-                <a:latin typeface="Arial"/>
-              </a:defRPr>
-            </a:pPr>
-            <a:r>
-              <a:rPr sz="1600">
-                <a:solidFill>
-                  <a:srgbClr val="111111"/>
-                </a:solidFill>
-                <a:latin typeface="Arial"/>
-              </a:rPr>
-              <a:t>MFA (Multi-Factor Authentication): Requires two or more verification factors for access.</a:t>
-            </a:r>
-          </a:p>
-          <a:p>
-            <a:pPr algn="l">
-              <a:defRPr sz="1600">
-                <a:solidFill>
-                  <a:srgbClr val="111111"/>
-                </a:solidFill>
-                <a:latin typeface="Arial"/>
-              </a:defRPr>
-            </a:pPr>
-            <a:r>
-              <a:rPr sz="1600">
-                <a:solidFill>
-                  <a:srgbClr val="111111"/>
-                </a:solidFill>
-                <a:latin typeface="Arial"/>
-              </a:rPr>
-              <a:t>Ransomware: Malware that encrypts data, demanding payment for decryption.</a:t>
-            </a:r>
-          </a:p>
-          <a:p>
-            <a:pPr algn="l">
-              <a:defRPr sz="1600">
-                <a:solidFill>
-                  <a:srgbClr val="111111"/>
-                </a:solidFill>
-                <a:latin typeface="Arial"/>
-              </a:defRPr>
-            </a:pPr>
-            <a:r>
-              <a:rPr sz="1600">
-                <a:solidFill>
-                  <a:srgbClr val="111111"/>
-                </a:solidFill>
-                <a:latin typeface="Arial"/>
-              </a:rPr>
-              <a:t>SOC (Security Operations Center): Centralized unit handling security incidents.</a:t>
-            </a:r>
-          </a:p>
-          <a:p>
-            <a:pPr algn="l">
-              <a:defRPr sz="1600">
-                <a:solidFill>
-                  <a:srgbClr val="111111"/>
-                </a:solidFill>
-                <a:latin typeface="Arial"/>
-              </a:defRPr>
-            </a:pPr>
-            <a:r>
-              <a:rPr sz="1600">
-                <a:solidFill>
-                  <a:srgbClr val="111111"/>
-                </a:solidFill>
-                <a:latin typeface="Arial"/>
-              </a:rPr>
-              <a:t>SIEM (Security Information and Event Management): System for collecting and analyzing security data.</a:t>
-            </a:r>
-          </a:p>
-        </p:txBody>
-      </p:sp>
-    </p:spTree>
-  </p:cSld>
-  <p:clrMapOvr>
-    <a:masterClrMapping/>
-  </p:clrMapOvr>
-</p:sld>
-</file>
-
-<file path=ppt/slides/slide2.xml><?xml version="1.0" encoding="utf-8"?>
-<p:sld xmlns:a="http://schemas.openxmlformats.org/drawingml/2006/main" xmlns:p="http://schemas.openxmlformats.org/presentationml/2006/main" xmlns:r="http://schemas.openxmlformats.org/officeDocument/2006/relationships">
-  <p:cSld>
-    <p:spTree>
-      <p:nvGrpSpPr>
-        <p:cNvPr id="1" name=""/>
-        <p:cNvGrpSpPr/>
-        <p:nvPr/>
-      </p:nvGrpSpPr>
-      <p:grpSpPr/>
-      <p:sp>
-        <p:nvSpPr>
-          <p:cNvPr id="2" name="Title 1"/>
-          <p:cNvSpPr>
-            <a:spLocks noGrp="1"/>
-          </p:cNvSpPr>
-          <p:nvPr>
-            <p:ph type="title"/>
-          </p:nvPr>
-        </p:nvSpPr>
-        <p:spPr>
-          <a:xfrm>
-            <a:off x="571500" y="571500"/>
-            <a:ext cx="11045952" cy="914400"/>
-          </a:xfrm>
-        </p:spPr>
-        <p:txBody>
-          <a:bodyPr/>
-          <a:lstStyle/>
-          <a:p>
-            <a:pPr algn="ctr">
-              <a:defRPr sz="2800" b="1">
-                <a:solidFill>
-                  <a:srgbClr val="111111"/>
-                </a:solidFill>
-                <a:latin typeface="Arial"/>
-              </a:defRPr>
-            </a:pPr>
-            <a:r>
-              <a:rPr sz="2800" b="1">
-                <a:solidFill>
-                  <a:srgbClr val="111111"/>
-                </a:solidFill>
-                <a:latin typeface="Arial"/>
-              </a:rPr>
-              <a:t>Presentation Overview</a:t>
-            </a:r>
-          </a:p>
-        </p:txBody>
-      </p:sp>
-      <p:sp>
-        <p:nvSpPr>
-          <p:cNvPr id="3" name="Content Placeholder 2"/>
-          <p:cNvSpPr>
-            <a:spLocks noGrp="1"/>
-          </p:cNvSpPr>
-          <p:nvPr>
-            <p:ph idx="1"/>
-          </p:nvPr>
-        </p:nvSpPr>
-        <p:spPr>
-          <a:xfrm>
-            <a:off x="571500" y="1557337"/>
-            <a:ext cx="6133315" cy="4729162"/>
-          </a:xfrm>
-        </p:spPr>
-        <p:txBody>
-          <a:bodyPr wrap="square">
-            <a:noAutofit/>
-          </a:bodyPr>
-          <a:lstStyle/>
-          <a:p>
-            <a:pPr algn="l">
-              <a:defRPr sz="1600">
-                <a:solidFill>
-                  <a:srgbClr val="111111"/>
-                </a:solidFill>
-                <a:latin typeface="Arial"/>
-              </a:defRPr>
-            </a:pPr>
-            <a:r>
-              <a:rPr sz="1600">
-                <a:solidFill>
-                  <a:srgbClr val="111111"/>
-                </a:solidFill>
-                <a:latin typeface="Arial"/>
-              </a:rPr>
-              <a:t>Executive Summary: Strategic Imperatives for Cyber Resilience</a:t>
-            </a:r>
-          </a:p>
-          <a:p>
-            <a:pPr algn="l">
-              <a:defRPr sz="1600">
-                <a:solidFill>
-                  <a:srgbClr val="111111"/>
-                </a:solidFill>
-                <a:latin typeface="Arial"/>
-              </a:defRPr>
-            </a:pPr>
-            <a:r>
-              <a:rPr sz="1600">
-                <a:solidFill>
-                  <a:srgbClr val="111111"/>
-                </a:solidFill>
-                <a:latin typeface="Arial"/>
-              </a:rPr>
-              <a:t>Understanding the Evolving Threat Landscape and Zero Trust Architecture</a:t>
-            </a:r>
-          </a:p>
-          <a:p>
-            <a:pPr algn="l">
-              <a:defRPr sz="1600">
-                <a:solidFill>
-                  <a:srgbClr val="111111"/>
-                </a:solidFill>
-                <a:latin typeface="Arial"/>
-              </a:defRPr>
-            </a:pPr>
-            <a:r>
-              <a:rPr sz="1600">
-                <a:solidFill>
-                  <a:srgbClr val="111111"/>
-                </a:solidFill>
-                <a:latin typeface="Arial"/>
-              </a:rPr>
-              <a:t>Key Trends: AI in Cyber Defense and Incident Response</a:t>
-            </a:r>
-          </a:p>
-          <a:p>
-            <a:pPr algn="l">
-              <a:defRPr sz="1600">
-                <a:solidFill>
-                  <a:srgbClr val="111111"/>
-                </a:solidFill>
-                <a:latin typeface="Arial"/>
-              </a:defRPr>
-            </a:pPr>
-            <a:r>
-              <a:rPr sz="1600">
-                <a:solidFill>
-                  <a:srgbClr val="111111"/>
-                </a:solidFill>
-                <a:latin typeface="Arial"/>
-              </a:rPr>
-              <a:t>Case Studies: Real-world applications and lessons learned</a:t>
-            </a:r>
-          </a:p>
-          <a:p>
-            <a:pPr algn="l">
-              <a:defRPr sz="1600">
-                <a:solidFill>
-                  <a:srgbClr val="111111"/>
-                </a:solidFill>
-                <a:latin typeface="Arial"/>
-              </a:defRPr>
-            </a:pPr>
-            <a:r>
-              <a:rPr sz="1600">
-                <a:solidFill>
-                  <a:srgbClr val="111111"/>
-                </a:solidFill>
-                <a:latin typeface="Arial"/>
-              </a:rPr>
-              <a:t>Action Plan: Strengthening Your Cyber Posture</a:t>
-            </a:r>
-          </a:p>
-        </p:txBody>
-      </p:sp>
-    </p:spTree>
-  </p:cSld>
-  <p:clrMapOvr>
-    <a:masterClrMapping/>
-  </p:clrMapOvr>
-</p:sld>
-</file>
-
-<file path=ppt/slides/slide3.xml><?xml version="1.0" encoding="utf-8"?>
-<p:sld xmlns:a="http://schemas.openxmlformats.org/drawingml/2006/main" xmlns:p="http://schemas.openxmlformats.org/presentationml/2006/main" xmlns:r="http://schemas.openxmlformats.org/officeDocument/2006/relationships">
-  <p:cSld>
-    <p:spTree>
-      <p:nvGrpSpPr>
-        <p:cNvPr id="1" name=""/>
-        <p:cNvGrpSpPr/>
-        <p:nvPr/>
-      </p:nvGrpSpPr>
-      <p:grpSpPr/>
-      <p:sp>
-        <p:nvSpPr>
-          <p:cNvPr id="2" name="Title 1"/>
-          <p:cNvSpPr>
-            <a:spLocks noGrp="1"/>
-          </p:cNvSpPr>
-          <p:nvPr>
-            <p:ph type="title"/>
-          </p:nvPr>
-        </p:nvSpPr>
-        <p:spPr>
-          <a:xfrm>
-            <a:off x="571500" y="571500"/>
-            <a:ext cx="11045952" cy="914400"/>
-          </a:xfrm>
-        </p:spPr>
-        <p:txBody>
-          <a:bodyPr/>
-          <a:lstStyle/>
-          <a:p>
-            <a:pPr algn="ctr">
-              <a:defRPr sz="2800" b="1">
-                <a:solidFill>
-                  <a:srgbClr val="111111"/>
-                </a:solidFill>
-                <a:latin typeface="Arial"/>
-              </a:defRPr>
-            </a:pPr>
-            <a:r>
-              <a:rPr sz="2800" b="1">
-                <a:solidFill>
-                  <a:srgbClr val="111111"/>
-                </a:solidFill>
-                <a:latin typeface="Arial"/>
-              </a:rPr>
-              <a:t>Executive Summary: Strategic Imperatives for Cyber Resilience</a:t>
-            </a:r>
-          </a:p>
-        </p:txBody>
-      </p:sp>
-      <p:sp>
-        <p:nvSpPr>
-          <p:cNvPr id="3" name="Content Placeholder 2"/>
-          <p:cNvSpPr>
-            <a:spLocks noGrp="1"/>
-          </p:cNvSpPr>
-          <p:nvPr>
-            <p:ph idx="1"/>
-          </p:nvPr>
-        </p:nvSpPr>
-        <p:spPr>
-          <a:xfrm>
-            <a:off x="571500" y="1557337"/>
-            <a:ext cx="6133315" cy="4729162"/>
-          </a:xfrm>
-        </p:spPr>
-        <p:txBody>
-          <a:bodyPr wrap="square">
-            <a:noAutofit/>
-          </a:bodyPr>
-          <a:lstStyle/>
-          <a:p>
-            <a:pPr algn="l">
-              <a:defRPr sz="1600">
-                <a:solidFill>
-                  <a:srgbClr val="111111"/>
-                </a:solidFill>
-                <a:latin typeface="Arial"/>
-              </a:defRPr>
-            </a:pPr>
-            <a:r>
-              <a:rPr sz="1600">
-                <a:solidFill>
-                  <a:srgbClr val="111111"/>
-                </a:solidFill>
-                <a:latin typeface="Arial"/>
-              </a:rPr>
-              <a:t>Situation: Cyber threats are escalating in sophistication and volume, targeting all sectors.</a:t>
-            </a:r>
-          </a:p>
-          <a:p>
-            <a:pPr algn="l">
-              <a:defRPr sz="1600">
-                <a:solidFill>
-                  <a:srgbClr val="111111"/>
-                </a:solidFill>
-                <a:latin typeface="Arial"/>
-              </a:defRPr>
-            </a:pPr>
-            <a:r>
-              <a:rPr sz="1600">
-                <a:solidFill>
-                  <a:srgbClr val="111111"/>
-                </a:solidFill>
-                <a:latin typeface="Arial"/>
-              </a:rPr>
-              <a:t>Complication: Traditional perimeter defenses are insufficient against advanced persistent threats and hybrid work…</a:t>
-            </a:r>
-          </a:p>
-          <a:p>
-            <a:pPr algn="l">
-              <a:defRPr sz="1600">
-                <a:solidFill>
-                  <a:srgbClr val="111111"/>
-                </a:solidFill>
-                <a:latin typeface="Arial"/>
-              </a:defRPr>
-            </a:pPr>
-            <a:r>
-              <a:rPr sz="1600">
-                <a:solidFill>
-                  <a:srgbClr val="111111"/>
-                </a:solidFill>
-                <a:latin typeface="Arial"/>
-              </a:rPr>
-              <a:t>Answer: Proactive, adaptive strategies like Zero Trust and AI-driven defense are essential for robust cyber resilience.</a:t>
-            </a:r>
-          </a:p>
-          <a:p>
-            <a:pPr algn="l">
-              <a:defRPr sz="1600">
-                <a:solidFill>
-                  <a:srgbClr val="111111"/>
-                </a:solidFill>
-                <a:latin typeface="Arial"/>
-              </a:defRPr>
-            </a:pPr>
-            <a:r>
-              <a:rPr sz="1600">
-                <a:solidFill>
-                  <a:srgbClr val="111111"/>
-                </a:solidFill>
-                <a:latin typeface="Arial"/>
-              </a:rPr>
-              <a:t>Takeaway: Organizations must prioritize continuous security posture improvement and rapid incident response…</a:t>
-            </a:r>
-          </a:p>
-        </p:txBody>
-      </p:sp>
-    </p:spTree>
-  </p:cSld>
-  <p:clrMapOvr>
-    <a:masterClrMapping/>
-  </p:clrMapOvr>
-</p:sld>
-</file>
-
 <file path=ppt/slides/slide4.xml><?xml version="1.0" encoding="utf-8"?>
 <p:sld xmlns:a="http://schemas.openxmlformats.org/drawingml/2006/main" xmlns:p="http://schemas.openxmlformats.org/presentationml/2006/main" xmlns:r="http://schemas.openxmlformats.org/officeDocument/2006/relationships">
   <p:cSld>
@@ -4665,7 +3971,7 @@
                 </a:solidFill>
                 <a:latin typeface="Arial"/>
               </a:rPr>
-              <a:t>Insight: The Evolving Threat Landscape</a:t>
+              <a:t>AKS: A Business Analogy for Managed Orchestration</a:t>
             </a:r>
           </a:p>
         </p:txBody>
@@ -4707,7 +4013,7 @@
                 </a:solidFill>
                 <a:latin typeface="Arial"/>
               </a:rPr>
-              <a:t>Definition: Modern threats include sophisticated ransomware, supply chain attacks, and nation-state sponsored cyber…</a:t>
+              <a:t>Imagine a highly automated factory floor for software production.</a:t>
             </a:r>
           </a:p>
           <a:p>
@@ -4726,7 +4032,7 @@
                 </a:solidFill>
                 <a:latin typeface="Arial"/>
               </a:rPr>
-              <a:t>Business Analogy: Organizations face a constant, multi-front digital siege, requiring layered defenses.</a:t>
+              <a:t>AKS manages the machinery (Kubernetes) and underlying infrastructure.</a:t>
             </a:r>
           </a:p>
           <a:p>
@@ -4745,7 +4051,7 @@
                 </a:solidFill>
                 <a:latin typeface="Arial"/>
               </a:rPr>
-              <a:t>Impact: Breaches lead to significant financial losses, reputational damage, and operational disruption.</a:t>
+              <a:t>Teams focus on building products (applications), not maintaining tools.</a:t>
             </a:r>
           </a:p>
           <a:p>
@@ -4764,14 +4070,14 @@
                 </a:solidFill>
                 <a:latin typeface="Arial"/>
               </a:rPr>
-              <a:t>Trend: Attackers increasingly leverage automation and AI to scale their malicious campaigns.</a:t>
+              <a:t>Ensures consistent production and rapid scaling on demand.</a:t>
             </a:r>
           </a:p>
         </p:txBody>
       </p:sp>
       <p:pic>
         <p:nvPicPr>
-          <p:cNvPr id="4" name="Picture 3" descr="slide_0_0.png"/>
+          <p:cNvPr id="4" name="Picture 3" descr="slide_8_3.png"/>
           <p:cNvPicPr>
             <a:picLocks noChangeAspect="1"/>
           </p:cNvPicPr>
@@ -4846,7 +4152,7 @@
                 </a:solidFill>
                 <a:latin typeface="Arial"/>
               </a:rPr>
-              <a:t>Insight: Understanding Modern Attack Vectors</a:t>
+              <a:t>Azure AKS Architecture: Core Components</a:t>
             </a:r>
           </a:p>
         </p:txBody>
@@ -4888,7 +4194,7 @@
                 </a:solidFill>
                 <a:latin typeface="Arial"/>
               </a:rPr>
-              <a:t>Technical Sidebar: Phishing, malware, and zero-day exploits remain prevalent entry points for attackers.</a:t>
+              <a:t>**Control Plane:** Managed by Azure, handles orchestration tasks and cluster state.</a:t>
             </a:r>
           </a:p>
           <a:p>
@@ -4907,7 +4213,7 @@
                 </a:solidFill>
                 <a:latin typeface="Arial"/>
               </a:rPr>
-              <a:t>Technical Sidebar: Attackers exploit misconfigurations, unpatched vulnerabilities, and weak credentials.</a:t>
+              <a:t>**Worker Nodes:** Your virtual machines running containerized applications.</a:t>
             </a:r>
           </a:p>
           <a:p>
@@ -4926,7 +4232,7 @@
                 </a:solidFill>
                 <a:latin typeface="Arial"/>
               </a:rPr>
-              <a:t>Diagram: Visualizing the attack kill chain helps identify critical intervention points.</a:t>
+              <a:t>Leverages Azure networking, storage, and monitoring for robust operations.</a:t>
             </a:r>
           </a:p>
           <a:p>
@@ -4945,35 +4251,11 @@
                 </a:solidFill>
                 <a:latin typeface="Arial"/>
               </a:rPr>
-              <a:t>Focus: Understanding these vectors is crucial for developing effective defensive strategies.</a:t>
-            </a:r>
-          </a:p>
-        </p:txBody>
-      </p:sp>
-      <p:pic>
-        <p:nvPicPr>
-          <p:cNvPr id="4" name="Picture 3" descr="slide_0_0.png"/>
-          <p:cNvPicPr>
-            <a:picLocks noChangeAspect="1"/>
-          </p:cNvPicPr>
-          <p:nvPr/>
-        </p:nvPicPr>
-        <p:blipFill>
-          <a:blip r:embed="rId2"/>
-          <a:stretch>
-            <a:fillRect/>
-          </a:stretch>
-        </p:blipFill>
-        <p:spPr>
-          <a:xfrm>
-            <a:off x="6990565" y="1557337"/>
-            <a:ext cx="4626886" cy="2699017"/>
-          </a:xfrm>
-          <a:prstGeom prst="rect">
-            <a:avLst/>
-          </a:prstGeom>
-        </p:spPr>
-      </p:pic>
+              <a:t>Provides high availability and automated upgrades for core components.</a:t>
+            </a:r>
+          </a:p>
+        </p:txBody>
+      </p:sp>
     </p:spTree>
   </p:cSld>
   <p:clrMapOvr>
@@ -5027,7 +4309,7 @@
                 </a:solidFill>
                 <a:latin typeface="Arial"/>
               </a:rPr>
-              <a:t>Insight: Zero Trust Architecture Explained</a:t>
+              <a:t>Key Benefits: Driving Efficiency and Innovation</a:t>
             </a:r>
           </a:p>
         </p:txBody>
@@ -5069,7 +4351,7 @@
                 </a:solidFill>
                 <a:latin typeface="Arial"/>
               </a:rPr>
-              <a:t>Definition: Zero Trust assumes no implicit trust for any user, device, or application, inside or outside the network.</a:t>
+              <a:t>**Scalability:** Automatically adjusts resources to meet fluctuating demand.</a:t>
             </a:r>
           </a:p>
           <a:p>
@@ -5088,7 +4370,7 @@
                 </a:solidFill>
                 <a:latin typeface="Arial"/>
               </a:rPr>
-              <a:t>Business Analogy: Treat every access request as if it originates from an untrusted network segment.</a:t>
+              <a:t>**Developer Agility:** Accelerates development cycles with consistent environments.</a:t>
             </a:r>
           </a:p>
           <a:p>
@@ -5107,7 +4389,7 @@
                 </a:solidFill>
                 <a:latin typeface="Arial"/>
               </a:rPr>
-              <a:t>Principle: The core tenet is 'never trust, always verify' for all interactions and data access.</a:t>
+              <a:t>**Operational Efficiency:** Reduces infrastructure management burden and costs.</a:t>
             </a:r>
           </a:p>
           <a:p>
@@ -5126,35 +4408,11 @@
                 </a:solidFill>
                 <a:latin typeface="Arial"/>
               </a:rPr>
-              <a:t>Benefit: Reduces the attack surface and limits lateral movement of threats within the environment.</a:t>
-            </a:r>
-          </a:p>
-        </p:txBody>
-      </p:sp>
-      <p:pic>
-        <p:nvPicPr>
-          <p:cNvPr id="4" name="Picture 3" descr="slide_0_0.png"/>
-          <p:cNvPicPr>
-            <a:picLocks noChangeAspect="1"/>
-          </p:cNvPicPr>
-          <p:nvPr/>
-        </p:nvPicPr>
-        <p:blipFill>
-          <a:blip r:embed="rId2"/>
-          <a:stretch>
-            <a:fillRect/>
-          </a:stretch>
-        </p:blipFill>
-        <p:spPr>
-          <a:xfrm>
-            <a:off x="6990565" y="1557337"/>
-            <a:ext cx="4626886" cy="2699017"/>
-          </a:xfrm>
-          <a:prstGeom prst="rect">
-            <a:avLst/>
-          </a:prstGeom>
-        </p:spPr>
-      </p:pic>
+              <a:t>**Cost Optimization:** Pay-as-you-go model with efficient resource utilization.</a:t>
+            </a:r>
+          </a:p>
+        </p:txBody>
+      </p:sp>
     </p:spTree>
   </p:cSld>
   <p:clrMapOvr>
@@ -5208,7 +4466,7 @@
                 </a:solidFill>
                 <a:latin typeface="Arial"/>
               </a:rPr>
-              <a:t>Insight: Implementing Zero Trust Principles</a:t>
+              <a:t>Enhancing Security and Governance with AKS</a:t>
             </a:r>
           </a:p>
         </p:txBody>
@@ -5250,7 +4508,7 @@
                 </a:solidFill>
                 <a:latin typeface="Arial"/>
               </a:rPr>
-              <a:t>Technical Sidebar: Micro-segmentation isolates workloads and limits lateral movement within networks.</a:t>
+              <a:t>Integrates with Azure Active Directory for robust identity management.</a:t>
             </a:r>
           </a:p>
           <a:p>
@@ -5269,7 +4527,7 @@
                 </a:solidFill>
                 <a:latin typeface="Arial"/>
               </a:rPr>
-              <a:t>Technical Sidebar: Strong multi-factor authentication (MFA) is mandatory for all access requests.</a:t>
+              <a:t>Implements network policies for secure communication between services.</a:t>
             </a:r>
           </a:p>
           <a:p>
@@ -5288,7 +4546,7 @@
                 </a:solidFill>
                 <a:latin typeface="Arial"/>
               </a:rPr>
-              <a:t>Diagram: Illustrates the continuous verification process across users, devices, and applications.</a:t>
+              <a:t>Leverages Azure Security Center for continuous threat detection and protection.</a:t>
             </a:r>
           </a:p>
           <a:p>
@@ -5307,35 +4565,11 @@
                 </a:solidFill>
                 <a:latin typeface="Arial"/>
               </a:rPr>
-              <a:t>Strategy: Requires integrating identity, device posture, and network context for dynamic access control.</a:t>
-            </a:r>
-          </a:p>
-        </p:txBody>
-      </p:sp>
-      <p:pic>
-        <p:nvPicPr>
-          <p:cNvPr id="4" name="Picture 3" descr="slide_0_0.png"/>
-          <p:cNvPicPr>
-            <a:picLocks noChangeAspect="1"/>
-          </p:cNvPicPr>
-          <p:nvPr/>
-        </p:nvPicPr>
-        <p:blipFill>
-          <a:blip r:embed="rId2"/>
-          <a:stretch>
-            <a:fillRect/>
-          </a:stretch>
-        </p:blipFill>
-        <p:spPr>
-          <a:xfrm>
-            <a:off x="6990565" y="1557337"/>
-            <a:ext cx="4626886" cy="2699017"/>
-          </a:xfrm>
-          <a:prstGeom prst="rect">
-            <a:avLst/>
-          </a:prstGeom>
-        </p:spPr>
-      </p:pic>
+              <a:t>Ensures compliance with built-in governance tools and policies.</a:t>
+            </a:r>
+          </a:p>
+        </p:txBody>
+      </p:sp>
     </p:spTree>
   </p:cSld>
   <p:clrMapOvr>
@@ -5389,7 +4623,7 @@
                 </a:solidFill>
                 <a:latin typeface="Arial"/>
               </a:rPr>
-              <a:t>Data: Global Cybersecurity Spending Trends</a:t>
+              <a:t>Streamlining DevOps Practices with AKS</a:t>
             </a:r>
           </a:p>
         </p:txBody>
@@ -5431,7 +4665,7 @@
                 </a:solidFill>
                 <a:latin typeface="Arial"/>
               </a:rPr>
-              <a:t>Growth: Global cybersecurity market projected to reach $260 billion by 2027, reflecting increased urgency.</a:t>
+              <a:t>Facilitates continuous integration and continuous delivery (CI/CD) pipelines.</a:t>
             </a:r>
           </a:p>
           <a:p>
@@ -5450,7 +4684,7 @@
                 </a:solidFill>
                 <a:latin typeface="Arial"/>
               </a:rPr>
-              <a:t>Investment: Significant spending increases in cloud security, threat intelligence, and security automation.</a:t>
+              <a:t>Supports GitOps for declarative infrastructure and application management.</a:t>
             </a:r>
           </a:p>
           <a:p>
@@ -5469,7 +4703,7 @@
                 </a:solidFill>
                 <a:latin typeface="Arial"/>
               </a:rPr>
-              <a:t>Priorities: Organizations prioritize breach prevention, rapid incident response, and compliance solutions.</a:t>
+              <a:t>Automates deployments and rollbacks for faster, more reliable releases.</a:t>
             </a:r>
           </a:p>
           <a:p>
@@ -5488,26 +4722,7 @@
                 </a:solidFill>
                 <a:latin typeface="Arial"/>
               </a:rPr>
-              <a:t>Shift: Move from reactive defense to proactive, intelligence-driven security investments.</a:t>
-            </a:r>
-          </a:p>
-          <a:p>
-            <a:pPr algn="l">
-              <a:defRPr sz="1600">
-                <a:solidFill>
-                  <a:srgbClr val="111111"/>
-                </a:solidFill>
-                <a:latin typeface="Arial"/>
-              </a:defRPr>
-            </a:pPr>
-            <a:r>
-              <a:rPr sz="1600">
-                <a:solidFill>
-                  <a:srgbClr val="111111"/>
-                </a:solidFill>
-                <a:latin typeface="Arial"/>
-              </a:rPr>
-              <a:t>Source: Market projections indicate continued growth driven by evolving threats and regulatory demands [Gartner, 2023].</a:t>
+              <a:t>Fosters collaboration between development and operations teams.</a:t>
             </a:r>
           </a:p>
         </p:txBody>
@@ -5565,7 +4780,7 @@
                 </a:solidFill>
                 <a:latin typeface="Arial"/>
               </a:rPr>
-              <a:t>Insight: AI's Role in Cyber Defense</a:t>
+              <a:t>Case Study: Global Retailer's Digital Transformation</a:t>
             </a:r>
           </a:p>
         </p:txBody>
@@ -5607,7 +4822,7 @@
                 </a:solidFill>
                 <a:latin typeface="Arial"/>
               </a:rPr>
-              <a:t>Detection: AI/ML algorithms enhance anomaly detection and predict emerging threats with greater accuracy.</a:t>
+              <a:t>**Challenge:** Slow application deployment and scaling issues during peak seasons.</a:t>
             </a:r>
           </a:p>
           <a:p>
@@ -5626,7 +4841,7 @@
                 </a:solidFill>
                 <a:latin typeface="Arial"/>
               </a:rPr>
-              <a:t>Automation: AI automates routine security tasks, improving response times and reducing human error.</a:t>
+              <a:t>**Solution:** Migrated core e-commerce platform to Azure AKS.</a:t>
             </a:r>
           </a:p>
           <a:p>
@@ -5645,7 +4860,7 @@
                 </a:solidFill>
                 <a:latin typeface="Arial"/>
               </a:rPr>
-              <a:t>Challenges: Ethical considerations and the potential for AI-powered attacks require careful management.</a:t>
+              <a:t>**Results:** Achieved 40% faster feature delivery and 99.9% uptime [Infosys Research, 2023].</a:t>
             </a:r>
           </a:p>
           <a:p>
@@ -5664,7 +4879,7 @@
                 </a:solidFill>
                 <a:latin typeface="Arial"/>
               </a:rPr>
-              <a:t>Future: AI will continue to be a critical enabler for scalable and intelligent cyber defenses.</a:t>
+              <a:t>Realized significant cost savings on infrastructure and operations.</a:t>
             </a:r>
           </a:p>
         </p:txBody>

</xml_diff>